<commit_message>
Procedure GET_GEFANGENEN_TERMINE und Datei controllers/get_termine.php hinzugefügt, weil vorher mit SELECTS im public Ordner die Funktion implementiert wurde. Proceduren umbenannt. Zwei Tabellen in eine zusammengefasst
</commit_message>
<xml_diff>
--- a/Präsentationen/15.07.26_Abschlusspräsi-LockedVisit.pptx
+++ b/Präsentationen/15.07.26_Abschlusspräsi-LockedVisit.pptx
@@ -6,12 +6,14 @@
   </p:sldMasterIdLst>
   <p:sldIdLst>
     <p:sldId id="256" r:id="rId2"/>
-    <p:sldId id="257" r:id="rId3"/>
-    <p:sldId id="258" r:id="rId4"/>
-    <p:sldId id="259" r:id="rId5"/>
-    <p:sldId id="260" r:id="rId6"/>
-    <p:sldId id="262" r:id="rId7"/>
-    <p:sldId id="261" r:id="rId8"/>
+    <p:sldId id="264" r:id="rId3"/>
+    <p:sldId id="257" r:id="rId4"/>
+    <p:sldId id="258" r:id="rId5"/>
+    <p:sldId id="259" r:id="rId6"/>
+    <p:sldId id="260" r:id="rId7"/>
+    <p:sldId id="262" r:id="rId8"/>
+    <p:sldId id="263" r:id="rId9"/>
+    <p:sldId id="261" r:id="rId10"/>
   </p:sldIdLst>
   <p:sldSz cx="12192000" cy="6858000"/>
   <p:notesSz cx="6858000" cy="9144000"/>
@@ -110,6 +112,11 @@
       </a:defRPr>
     </a:lvl9pPr>
   </p:defaultTextStyle>
+  <p:extLst>
+    <p:ext uri="{EFAFB233-063F-42B5-8137-9DF3F51BA10A}">
+      <p15:sldGuideLst xmlns:p15="http://schemas.microsoft.com/office/powerpoint/2012/main"/>
+    </p:ext>
+  </p:extLst>
 </p:presentation>
 </file>
 
@@ -260,7 +267,7 @@
           <a:p>
             <a:fld id="{3A093583-0075-4E53-AA2A-B577A915B774}" type="datetimeFigureOut">
               <a:rPr lang="de-DE" smtClean="0"/>
-              <a:t>14.07.2026</a:t>
+              <a:t>15.07.2026</a:t>
             </a:fld>
             <a:endParaRPr lang="de-DE"/>
           </a:p>
@@ -458,7 +465,7 @@
           <a:p>
             <a:fld id="{3A093583-0075-4E53-AA2A-B577A915B774}" type="datetimeFigureOut">
               <a:rPr lang="de-DE" smtClean="0"/>
-              <a:t>14.07.2026</a:t>
+              <a:t>15.07.2026</a:t>
             </a:fld>
             <a:endParaRPr lang="de-DE"/>
           </a:p>
@@ -666,7 +673,7 @@
           <a:p>
             <a:fld id="{3A093583-0075-4E53-AA2A-B577A915B774}" type="datetimeFigureOut">
               <a:rPr lang="de-DE" smtClean="0"/>
-              <a:t>14.07.2026</a:t>
+              <a:t>15.07.2026</a:t>
             </a:fld>
             <a:endParaRPr lang="de-DE"/>
           </a:p>
@@ -864,7 +871,7 @@
           <a:p>
             <a:fld id="{3A093583-0075-4E53-AA2A-B577A915B774}" type="datetimeFigureOut">
               <a:rPr lang="de-DE" smtClean="0"/>
-              <a:t>14.07.2026</a:t>
+              <a:t>15.07.2026</a:t>
             </a:fld>
             <a:endParaRPr lang="de-DE"/>
           </a:p>
@@ -1139,7 +1146,7 @@
           <a:p>
             <a:fld id="{3A093583-0075-4E53-AA2A-B577A915B774}" type="datetimeFigureOut">
               <a:rPr lang="de-DE" smtClean="0"/>
-              <a:t>14.07.2026</a:t>
+              <a:t>15.07.2026</a:t>
             </a:fld>
             <a:endParaRPr lang="de-DE"/>
           </a:p>
@@ -1404,7 +1411,7 @@
           <a:p>
             <a:fld id="{3A093583-0075-4E53-AA2A-B577A915B774}" type="datetimeFigureOut">
               <a:rPr lang="de-DE" smtClean="0"/>
-              <a:t>14.07.2026</a:t>
+              <a:t>15.07.2026</a:t>
             </a:fld>
             <a:endParaRPr lang="de-DE"/>
           </a:p>
@@ -1816,7 +1823,7 @@
           <a:p>
             <a:fld id="{3A093583-0075-4E53-AA2A-B577A915B774}" type="datetimeFigureOut">
               <a:rPr lang="de-DE" smtClean="0"/>
-              <a:t>14.07.2026</a:t>
+              <a:t>15.07.2026</a:t>
             </a:fld>
             <a:endParaRPr lang="de-DE"/>
           </a:p>
@@ -1957,7 +1964,7 @@
           <a:p>
             <a:fld id="{3A093583-0075-4E53-AA2A-B577A915B774}" type="datetimeFigureOut">
               <a:rPr lang="de-DE" smtClean="0"/>
-              <a:t>14.07.2026</a:t>
+              <a:t>15.07.2026</a:t>
             </a:fld>
             <a:endParaRPr lang="de-DE"/>
           </a:p>
@@ -2070,7 +2077,7 @@
           <a:p>
             <a:fld id="{3A093583-0075-4E53-AA2A-B577A915B774}" type="datetimeFigureOut">
               <a:rPr lang="de-DE" smtClean="0"/>
-              <a:t>14.07.2026</a:t>
+              <a:t>15.07.2026</a:t>
             </a:fld>
             <a:endParaRPr lang="de-DE"/>
           </a:p>
@@ -2381,7 +2388,7 @@
           <a:p>
             <a:fld id="{3A093583-0075-4E53-AA2A-B577A915B774}" type="datetimeFigureOut">
               <a:rPr lang="de-DE" smtClean="0"/>
-              <a:t>14.07.2026</a:t>
+              <a:t>15.07.2026</a:t>
             </a:fld>
             <a:endParaRPr lang="de-DE"/>
           </a:p>
@@ -2669,7 +2676,7 @@
           <a:p>
             <a:fld id="{3A093583-0075-4E53-AA2A-B577A915B774}" type="datetimeFigureOut">
               <a:rPr lang="de-DE" smtClean="0"/>
-              <a:t>14.07.2026</a:t>
+              <a:t>15.07.2026</a:t>
             </a:fld>
             <a:endParaRPr lang="de-DE"/>
           </a:p>
@@ -2910,7 +2917,7 @@
           <a:p>
             <a:fld id="{3A093583-0075-4E53-AA2A-B577A915B774}" type="datetimeFigureOut">
               <a:rPr lang="de-DE" smtClean="0"/>
-              <a:t>14.07.2026</a:t>
+              <a:t>15.07.2026</a:t>
             </a:fld>
             <a:endParaRPr lang="de-DE"/>
           </a:p>
@@ -3429,6 +3436,131 @@
           <p:cNvPr id="2" name="Titel 1">
             <a:extLst>
               <a:ext uri="{FF2B5EF4-FFF2-40B4-BE49-F238E27FC236}">
+                <a16:creationId xmlns:a16="http://schemas.microsoft.com/office/drawing/2014/main" id="{C87AB552-2A89-0A9B-96FE-621EDF9F793B}"/>
+              </a:ext>
+            </a:extLst>
+          </p:cNvPr>
+          <p:cNvSpPr>
+            <a:spLocks noGrp="1"/>
+          </p:cNvSpPr>
+          <p:nvPr>
+            <p:ph type="title"/>
+          </p:nvPr>
+        </p:nvSpPr>
+        <p:spPr/>
+        <p:txBody>
+          <a:bodyPr/>
+          <a:lstStyle/>
+          <a:p>
+            <a:r>
+              <a:rPr lang="de-DE" dirty="0"/>
+              <a:t>Agenda</a:t>
+            </a:r>
+          </a:p>
+        </p:txBody>
+      </p:sp>
+      <p:sp>
+        <p:nvSpPr>
+          <p:cNvPr id="3" name="Inhaltsplatzhalter 2">
+            <a:extLst>
+              <a:ext uri="{FF2B5EF4-FFF2-40B4-BE49-F238E27FC236}">
+                <a16:creationId xmlns:a16="http://schemas.microsoft.com/office/drawing/2014/main" id="{97B31EAC-F2AF-46FF-0AE6-1A331402CA54}"/>
+              </a:ext>
+            </a:extLst>
+          </p:cNvPr>
+          <p:cNvSpPr>
+            <a:spLocks noGrp="1"/>
+          </p:cNvSpPr>
+          <p:nvPr>
+            <p:ph idx="1"/>
+          </p:nvPr>
+        </p:nvSpPr>
+        <p:spPr/>
+        <p:txBody>
+          <a:bodyPr/>
+          <a:lstStyle/>
+          <a:p>
+            <a:r>
+              <a:rPr lang="de-DE" dirty="0"/>
+              <a:t>Wer sind wir?</a:t>
+            </a:r>
+          </a:p>
+          <a:p>
+            <a:r>
+              <a:rPr lang="de-DE" dirty="0"/>
+              <a:t>BPMN</a:t>
+            </a:r>
+          </a:p>
+          <a:p>
+            <a:r>
+              <a:rPr lang="de-DE" dirty="0"/>
+              <a:t>Datenbank-Anpassungen</a:t>
+            </a:r>
+          </a:p>
+          <a:p>
+            <a:r>
+              <a:rPr lang="de-DE" dirty="0"/>
+              <a:t>Verwendete Technologie</a:t>
+            </a:r>
+          </a:p>
+          <a:p>
+            <a:r>
+              <a:rPr lang="de-DE" dirty="0"/>
+              <a:t>User Story und Live-Vorstellung</a:t>
+            </a:r>
+          </a:p>
+          <a:p>
+            <a:r>
+              <a:rPr lang="de-DE" dirty="0" err="1"/>
+              <a:t>Stored</a:t>
+            </a:r>
+            <a:r>
+              <a:rPr lang="de-DE" dirty="0"/>
+              <a:t> </a:t>
+            </a:r>
+            <a:r>
+              <a:rPr lang="de-DE" dirty="0" err="1"/>
+              <a:t>Procedures</a:t>
+            </a:r>
+            <a:endParaRPr lang="de-DE" dirty="0"/>
+          </a:p>
+        </p:txBody>
+      </p:sp>
+    </p:spTree>
+    <p:extLst>
+      <p:ext uri="{BB962C8B-B14F-4D97-AF65-F5344CB8AC3E}">
+        <p14:creationId xmlns:p14="http://schemas.microsoft.com/office/powerpoint/2010/main" val="3226719553"/>
+      </p:ext>
+    </p:extLst>
+  </p:cSld>
+  <p:clrMapOvr>
+    <a:masterClrMapping/>
+  </p:clrMapOvr>
+</p:sld>
+</file>
+
+<file path=ppt/slides/slide3.xml><?xml version="1.0" encoding="utf-8"?>
+<p:sld xmlns:a="http://schemas.openxmlformats.org/drawingml/2006/main" xmlns:r="http://schemas.openxmlformats.org/officeDocument/2006/relationships" xmlns:p="http://schemas.openxmlformats.org/presentationml/2006/main">
+  <p:cSld>
+    <p:spTree>
+      <p:nvGrpSpPr>
+        <p:cNvPr id="1" name=""/>
+        <p:cNvGrpSpPr/>
+        <p:nvPr/>
+      </p:nvGrpSpPr>
+      <p:grpSpPr>
+        <a:xfrm>
+          <a:off x="0" y="0"/>
+          <a:ext cx="0" cy="0"/>
+          <a:chOff x="0" y="0"/>
+          <a:chExt cx="0" cy="0"/>
+        </a:xfrm>
+      </p:grpSpPr>
+      <p:sp>
+        <p:nvSpPr>
+          <p:cNvPr id="2" name="Titel 1">
+            <a:extLst>
+              <a:ext uri="{FF2B5EF4-FFF2-40B4-BE49-F238E27FC236}">
                 <a16:creationId xmlns:a16="http://schemas.microsoft.com/office/drawing/2014/main" id="{EADD8F38-2E5B-9C85-9FA9-D4F814E9DC96}"/>
               </a:ext>
             </a:extLst>
@@ -3505,7 +3637,7 @@
 </p:sld>
 </file>
 
-<file path=ppt/slides/slide3.xml><?xml version="1.0" encoding="utf-8"?>
+<file path=ppt/slides/slide4.xml><?xml version="1.0" encoding="utf-8"?>
 <p:sld xmlns:a="http://schemas.openxmlformats.org/drawingml/2006/main" xmlns:r="http://schemas.openxmlformats.org/officeDocument/2006/relationships" xmlns:p="http://schemas.openxmlformats.org/presentationml/2006/main">
   <p:cSld>
     <p:spTree>
@@ -3595,147 +3727,6 @@
 </p:sld>
 </file>
 
-<file path=ppt/slides/slide4.xml><?xml version="1.0" encoding="utf-8"?>
-<p:sld xmlns:a="http://schemas.openxmlformats.org/drawingml/2006/main" xmlns:r="http://schemas.openxmlformats.org/officeDocument/2006/relationships" xmlns:p="http://schemas.openxmlformats.org/presentationml/2006/main">
-  <p:cSld>
-    <p:spTree>
-      <p:nvGrpSpPr>
-        <p:cNvPr id="1" name=""/>
-        <p:cNvGrpSpPr/>
-        <p:nvPr/>
-      </p:nvGrpSpPr>
-      <p:grpSpPr>
-        <a:xfrm>
-          <a:off x="0" y="0"/>
-          <a:ext cx="0" cy="0"/>
-          <a:chOff x="0" y="0"/>
-          <a:chExt cx="0" cy="0"/>
-        </a:xfrm>
-      </p:grpSpPr>
-      <p:sp>
-        <p:nvSpPr>
-          <p:cNvPr id="2" name="Titel 1">
-            <a:extLst>
-              <a:ext uri="{FF2B5EF4-FFF2-40B4-BE49-F238E27FC236}">
-                <a16:creationId xmlns:a16="http://schemas.microsoft.com/office/drawing/2014/main" id="{26198534-6A49-7276-B3E0-364237537C90}"/>
-              </a:ext>
-            </a:extLst>
-          </p:cNvPr>
-          <p:cNvSpPr>
-            <a:spLocks noGrp="1"/>
-          </p:cNvSpPr>
-          <p:nvPr>
-            <p:ph type="title"/>
-          </p:nvPr>
-        </p:nvSpPr>
-        <p:spPr/>
-        <p:txBody>
-          <a:bodyPr/>
-          <a:lstStyle/>
-          <a:p>
-            <a:r>
-              <a:rPr lang="de-DE" dirty="0"/>
-              <a:t>Datenbank-Anpassungen</a:t>
-            </a:r>
-          </a:p>
-        </p:txBody>
-      </p:sp>
-      <p:sp>
-        <p:nvSpPr>
-          <p:cNvPr id="3" name="Inhaltsplatzhalter 2">
-            <a:extLst>
-              <a:ext uri="{FF2B5EF4-FFF2-40B4-BE49-F238E27FC236}">
-                <a16:creationId xmlns:a16="http://schemas.microsoft.com/office/drawing/2014/main" id="{830E3D1F-0625-DB75-00FD-4380654E32F6}"/>
-              </a:ext>
-            </a:extLst>
-          </p:cNvPr>
-          <p:cNvSpPr>
-            <a:spLocks noGrp="1"/>
-          </p:cNvSpPr>
-          <p:nvPr>
-            <p:ph idx="1"/>
-          </p:nvPr>
-        </p:nvSpPr>
-        <p:spPr/>
-        <p:txBody>
-          <a:bodyPr/>
-          <a:lstStyle/>
-          <a:p>
-            <a:r>
-              <a:rPr lang="de-DE" dirty="0"/>
-              <a:t>Tabellen:</a:t>
-            </a:r>
-          </a:p>
-          <a:p>
-            <a:pPr lvl="1"/>
-            <a:r>
-              <a:rPr lang="de-DE" dirty="0"/>
-              <a:t>BESUCHSZEITEN</a:t>
-            </a:r>
-          </a:p>
-          <a:p>
-            <a:pPr lvl="1"/>
-            <a:r>
-              <a:rPr lang="de-DE" dirty="0"/>
-              <a:t>GEFANGENEN_SLOTS</a:t>
-            </a:r>
-          </a:p>
-          <a:p>
-            <a:pPr lvl="1"/>
-            <a:r>
-              <a:rPr lang="de-DE" dirty="0"/>
-              <a:t>VALIDIERTE_BESUCHER</a:t>
-            </a:r>
-          </a:p>
-          <a:p>
-            <a:pPr lvl="1"/>
-            <a:r>
-              <a:rPr lang="de-DE" dirty="0"/>
-              <a:t>VALIDIERUNGSANTRAG</a:t>
-            </a:r>
-          </a:p>
-          <a:p>
-            <a:r>
-              <a:rPr lang="de-DE" dirty="0"/>
-              <a:t>Attribut:</a:t>
-            </a:r>
-          </a:p>
-          <a:p>
-            <a:pPr lvl="1"/>
-            <a:r>
-              <a:rPr lang="de-DE" dirty="0"/>
-              <a:t>BESUCHBAR in GEFANGENER hinzugefügt</a:t>
-            </a:r>
-          </a:p>
-          <a:p>
-            <a:pPr lvl="1"/>
-            <a:r>
-              <a:rPr lang="de-DE" dirty="0"/>
-              <a:t>EMAIL in PERSON auf NOT NULL</a:t>
-            </a:r>
-          </a:p>
-          <a:p>
-            <a:pPr lvl="1"/>
-            <a:r>
-              <a:rPr lang="de-DE" dirty="0"/>
-              <a:t>PASSWORT in PERSON hinzugefügt</a:t>
-            </a:r>
-          </a:p>
-        </p:txBody>
-      </p:sp>
-    </p:spTree>
-    <p:extLst>
-      <p:ext uri="{BB962C8B-B14F-4D97-AF65-F5344CB8AC3E}">
-        <p14:creationId xmlns:p14="http://schemas.microsoft.com/office/powerpoint/2010/main" val="4155906469"/>
-      </p:ext>
-    </p:extLst>
-  </p:cSld>
-  <p:clrMapOvr>
-    <a:masterClrMapping/>
-  </p:clrMapOvr>
-</p:sld>
-</file>
-
 <file path=ppt/slides/slide5.xml><?xml version="1.0" encoding="utf-8"?>
 <p:sld xmlns:a="http://schemas.openxmlformats.org/drawingml/2006/main" xmlns:r="http://schemas.openxmlformats.org/officeDocument/2006/relationships" xmlns:p="http://schemas.openxmlformats.org/presentationml/2006/main">
   <p:cSld>
@@ -3758,7 +3749,7 @@
           <p:cNvPr id="2" name="Titel 1">
             <a:extLst>
               <a:ext uri="{FF2B5EF4-FFF2-40B4-BE49-F238E27FC236}">
-                <a16:creationId xmlns:a16="http://schemas.microsoft.com/office/drawing/2014/main" id="{9A64F90E-5387-3D45-4B7F-0E088E0E6DB8}"/>
+                <a16:creationId xmlns:a16="http://schemas.microsoft.com/office/drawing/2014/main" id="{26198534-6A49-7276-B3E0-364237537C90}"/>
               </a:ext>
             </a:extLst>
           </p:cNvPr>
@@ -3776,7 +3767,7 @@
           <a:p>
             <a:r>
               <a:rPr lang="de-DE" dirty="0"/>
-              <a:t>Verwendete Technologie</a:t>
+              <a:t>Datenbank-Anpassungen</a:t>
             </a:r>
           </a:p>
         </p:txBody>
@@ -3786,7 +3777,7 @@
           <p:cNvPr id="3" name="Inhaltsplatzhalter 2">
             <a:extLst>
               <a:ext uri="{FF2B5EF4-FFF2-40B4-BE49-F238E27FC236}">
-                <a16:creationId xmlns:a16="http://schemas.microsoft.com/office/drawing/2014/main" id="{9FF012AC-EBDB-16DE-5E1F-7EBBB799408A}"/>
+                <a16:creationId xmlns:a16="http://schemas.microsoft.com/office/drawing/2014/main" id="{830E3D1F-0625-DB75-00FD-4380654E32F6}"/>
               </a:ext>
             </a:extLst>
           </p:cNvPr>
@@ -3804,13 +3795,62 @@
           <a:p>
             <a:r>
               <a:rPr lang="de-DE" dirty="0"/>
-              <a:t>PHP 8.2</a:t>
-            </a:r>
-          </a:p>
-          <a:p>
+              <a:t>Tabellen:</a:t>
+            </a:r>
+          </a:p>
+          <a:p>
+            <a:pPr lvl="1"/>
             <a:r>
               <a:rPr lang="de-DE" dirty="0"/>
-              <a:t>ORACLE DBMS</a:t>
+              <a:t>BESUCHSZEITEN</a:t>
+            </a:r>
+          </a:p>
+          <a:p>
+            <a:pPr lvl="1"/>
+            <a:r>
+              <a:rPr lang="de-DE" dirty="0"/>
+              <a:t>GEFANGENEN_SLOTS</a:t>
+            </a:r>
+          </a:p>
+          <a:p>
+            <a:pPr lvl="1"/>
+            <a:r>
+              <a:rPr lang="de-DE" dirty="0"/>
+              <a:t>VALIDIERTE_BESUCHER</a:t>
+            </a:r>
+          </a:p>
+          <a:p>
+            <a:pPr lvl="1"/>
+            <a:r>
+              <a:rPr lang="de-DE" dirty="0"/>
+              <a:t>VALIDIERUNGSANTRAG</a:t>
+            </a:r>
+          </a:p>
+          <a:p>
+            <a:r>
+              <a:rPr lang="de-DE" dirty="0"/>
+              <a:t>Attribut:</a:t>
+            </a:r>
+          </a:p>
+          <a:p>
+            <a:pPr lvl="1"/>
+            <a:r>
+              <a:rPr lang="de-DE" dirty="0"/>
+              <a:t>BESUCHBAR in GEFANGENER hinzugefügt</a:t>
+            </a:r>
+          </a:p>
+          <a:p>
+            <a:pPr lvl="1"/>
+            <a:r>
+              <a:rPr lang="de-DE" dirty="0"/>
+              <a:t>EMAIL in PERSON auf NOT NULL</a:t>
+            </a:r>
+          </a:p>
+          <a:p>
+            <a:pPr lvl="1"/>
+            <a:r>
+              <a:rPr lang="de-DE" dirty="0"/>
+              <a:t>PASSWORT in PERSON hinzugefügt</a:t>
             </a:r>
           </a:p>
         </p:txBody>
@@ -3818,7 +3858,7 @@
     </p:spTree>
     <p:extLst>
       <p:ext uri="{BB962C8B-B14F-4D97-AF65-F5344CB8AC3E}">
-        <p14:creationId xmlns:p14="http://schemas.microsoft.com/office/powerpoint/2010/main" val="3606827027"/>
+        <p14:creationId xmlns:p14="http://schemas.microsoft.com/office/powerpoint/2010/main" val="4155906469"/>
       </p:ext>
     </p:extLst>
   </p:cSld>
@@ -3850,6 +3890,98 @@
           <p:cNvPr id="2" name="Titel 1">
             <a:extLst>
               <a:ext uri="{FF2B5EF4-FFF2-40B4-BE49-F238E27FC236}">
+                <a16:creationId xmlns:a16="http://schemas.microsoft.com/office/drawing/2014/main" id="{9A64F90E-5387-3D45-4B7F-0E088E0E6DB8}"/>
+              </a:ext>
+            </a:extLst>
+          </p:cNvPr>
+          <p:cNvSpPr>
+            <a:spLocks noGrp="1"/>
+          </p:cNvSpPr>
+          <p:nvPr>
+            <p:ph type="title"/>
+          </p:nvPr>
+        </p:nvSpPr>
+        <p:spPr/>
+        <p:txBody>
+          <a:bodyPr/>
+          <a:lstStyle/>
+          <a:p>
+            <a:r>
+              <a:rPr lang="de-DE" dirty="0"/>
+              <a:t>Verwendete Technologie</a:t>
+            </a:r>
+          </a:p>
+        </p:txBody>
+      </p:sp>
+      <p:sp>
+        <p:nvSpPr>
+          <p:cNvPr id="3" name="Inhaltsplatzhalter 2">
+            <a:extLst>
+              <a:ext uri="{FF2B5EF4-FFF2-40B4-BE49-F238E27FC236}">
+                <a16:creationId xmlns:a16="http://schemas.microsoft.com/office/drawing/2014/main" id="{9FF012AC-EBDB-16DE-5E1F-7EBBB799408A}"/>
+              </a:ext>
+            </a:extLst>
+          </p:cNvPr>
+          <p:cNvSpPr>
+            <a:spLocks noGrp="1"/>
+          </p:cNvSpPr>
+          <p:nvPr>
+            <p:ph idx="1"/>
+          </p:nvPr>
+        </p:nvSpPr>
+        <p:spPr/>
+        <p:txBody>
+          <a:bodyPr/>
+          <a:lstStyle/>
+          <a:p>
+            <a:r>
+              <a:rPr lang="de-DE" dirty="0"/>
+              <a:t>PHP 8.2 mit oci8</a:t>
+            </a:r>
+          </a:p>
+          <a:p>
+            <a:r>
+              <a:rPr lang="de-DE" dirty="0"/>
+              <a:t>ORACLE DBMS</a:t>
+            </a:r>
+          </a:p>
+        </p:txBody>
+      </p:sp>
+    </p:spTree>
+    <p:extLst>
+      <p:ext uri="{BB962C8B-B14F-4D97-AF65-F5344CB8AC3E}">
+        <p14:creationId xmlns:p14="http://schemas.microsoft.com/office/powerpoint/2010/main" val="3606827027"/>
+      </p:ext>
+    </p:extLst>
+  </p:cSld>
+  <p:clrMapOvr>
+    <a:masterClrMapping/>
+  </p:clrMapOvr>
+</p:sld>
+</file>
+
+<file path=ppt/slides/slide7.xml><?xml version="1.0" encoding="utf-8"?>
+<p:sld xmlns:a="http://schemas.openxmlformats.org/drawingml/2006/main" xmlns:r="http://schemas.openxmlformats.org/officeDocument/2006/relationships" xmlns:p="http://schemas.openxmlformats.org/presentationml/2006/main">
+  <p:cSld>
+    <p:spTree>
+      <p:nvGrpSpPr>
+        <p:cNvPr id="1" name=""/>
+        <p:cNvGrpSpPr/>
+        <p:nvPr/>
+      </p:nvGrpSpPr>
+      <p:grpSpPr>
+        <a:xfrm>
+          <a:off x="0" y="0"/>
+          <a:ext cx="0" cy="0"/>
+          <a:chOff x="0" y="0"/>
+          <a:chExt cx="0" cy="0"/>
+        </a:xfrm>
+      </p:grpSpPr>
+      <p:sp>
+        <p:nvSpPr>
+          <p:cNvPr id="2" name="Titel 1">
+            <a:extLst>
+              <a:ext uri="{FF2B5EF4-FFF2-40B4-BE49-F238E27FC236}">
                 <a16:creationId xmlns:a16="http://schemas.microsoft.com/office/drawing/2014/main" id="{9341C3C7-EDCF-765E-CBBF-490AD4E57307}"/>
               </a:ext>
             </a:extLst>
@@ -3945,7 +4077,141 @@
 </p:sld>
 </file>
 
-<file path=ppt/slides/slide7.xml><?xml version="1.0" encoding="utf-8"?>
+<file path=ppt/slides/slide8.xml><?xml version="1.0" encoding="utf-8"?>
+<p:sld xmlns:a="http://schemas.openxmlformats.org/drawingml/2006/main" xmlns:r="http://schemas.openxmlformats.org/officeDocument/2006/relationships" xmlns:p="http://schemas.openxmlformats.org/presentationml/2006/main">
+  <p:cSld>
+    <p:spTree>
+      <p:nvGrpSpPr>
+        <p:cNvPr id="1" name=""/>
+        <p:cNvGrpSpPr/>
+        <p:nvPr/>
+      </p:nvGrpSpPr>
+      <p:grpSpPr>
+        <a:xfrm>
+          <a:off x="0" y="0"/>
+          <a:ext cx="0" cy="0"/>
+          <a:chOff x="0" y="0"/>
+          <a:chExt cx="0" cy="0"/>
+        </a:xfrm>
+      </p:grpSpPr>
+      <p:sp>
+        <p:nvSpPr>
+          <p:cNvPr id="2" name="Titel 1">
+            <a:extLst>
+              <a:ext uri="{FF2B5EF4-FFF2-40B4-BE49-F238E27FC236}">
+                <a16:creationId xmlns:a16="http://schemas.microsoft.com/office/drawing/2014/main" id="{F723E0AF-A76E-181C-9399-E4A8B47A6FFC}"/>
+              </a:ext>
+            </a:extLst>
+          </p:cNvPr>
+          <p:cNvSpPr>
+            <a:spLocks noGrp="1"/>
+          </p:cNvSpPr>
+          <p:nvPr>
+            <p:ph type="title"/>
+          </p:nvPr>
+        </p:nvSpPr>
+        <p:spPr/>
+        <p:txBody>
+          <a:bodyPr/>
+          <a:lstStyle/>
+          <a:p>
+            <a:r>
+              <a:rPr lang="de-DE" dirty="0" err="1"/>
+              <a:t>Stored</a:t>
+            </a:r>
+            <a:r>
+              <a:rPr lang="de-DE" dirty="0"/>
+              <a:t> </a:t>
+            </a:r>
+            <a:r>
+              <a:rPr lang="de-DE" dirty="0" err="1"/>
+              <a:t>Procedures</a:t>
+            </a:r>
+            <a:endParaRPr lang="de-DE" dirty="0"/>
+          </a:p>
+        </p:txBody>
+      </p:sp>
+      <p:sp>
+        <p:nvSpPr>
+          <p:cNvPr id="3" name="Inhaltsplatzhalter 2">
+            <a:extLst>
+              <a:ext uri="{FF2B5EF4-FFF2-40B4-BE49-F238E27FC236}">
+                <a16:creationId xmlns:a16="http://schemas.microsoft.com/office/drawing/2014/main" id="{0702FCD7-05B3-7A88-5501-6415757D0419}"/>
+              </a:ext>
+            </a:extLst>
+          </p:cNvPr>
+          <p:cNvSpPr>
+            <a:spLocks noGrp="1"/>
+          </p:cNvSpPr>
+          <p:nvPr>
+            <p:ph idx="1"/>
+          </p:nvPr>
+        </p:nvSpPr>
+        <p:spPr/>
+        <p:txBody>
+          <a:bodyPr/>
+          <a:lstStyle/>
+          <a:p>
+            <a:r>
+              <a:rPr lang="de-DE" dirty="0"/>
+              <a:t>REGISTRIERE_PERSON</a:t>
+            </a:r>
+          </a:p>
+          <a:p>
+            <a:r>
+              <a:rPr lang="de-DE" dirty="0"/>
+              <a:t>LOGIN_PERSON</a:t>
+            </a:r>
+          </a:p>
+          <a:p>
+            <a:r>
+              <a:rPr lang="de-DE" dirty="0"/>
+              <a:t>GET_VALIDIERTE_GEFANGENE</a:t>
+            </a:r>
+          </a:p>
+          <a:p>
+            <a:r>
+              <a:rPr lang="de-DE" dirty="0"/>
+              <a:t>GET_GEFANGENE_FUER_VALIDIERUNG</a:t>
+            </a:r>
+          </a:p>
+          <a:p>
+            <a:r>
+              <a:rPr lang="de-DE" dirty="0"/>
+              <a:t>GET_OFFENE_VALIDIERUNGEN</a:t>
+            </a:r>
+          </a:p>
+          <a:p>
+            <a:r>
+              <a:rPr lang="de-DE" dirty="0"/>
+              <a:t>VALIDIERUNGSANTRAG_STELLEN</a:t>
+            </a:r>
+          </a:p>
+          <a:p>
+            <a:r>
+              <a:rPr lang="de-DE" dirty="0"/>
+              <a:t>TERMIN_BUCHEN</a:t>
+            </a:r>
+          </a:p>
+          <a:p>
+            <a:endParaRPr lang="de-DE" dirty="0"/>
+          </a:p>
+        </p:txBody>
+      </p:sp>
+    </p:spTree>
+    <p:extLst>
+      <p:ext uri="{BB962C8B-B14F-4D97-AF65-F5344CB8AC3E}">
+        <p14:creationId xmlns:p14="http://schemas.microsoft.com/office/powerpoint/2010/main" val="402669019"/>
+      </p:ext>
+    </p:extLst>
+  </p:cSld>
+  <p:clrMapOvr>
+    <a:masterClrMapping/>
+  </p:clrMapOvr>
+</p:sld>
+</file>
+
+<file path=ppt/slides/slide9.xml><?xml version="1.0" encoding="utf-8"?>
 <p:sld xmlns:a="http://schemas.openxmlformats.org/drawingml/2006/main" xmlns:r="http://schemas.openxmlformats.org/officeDocument/2006/relationships" xmlns:p="http://schemas.openxmlformats.org/presentationml/2006/main">
   <p:cSld>
     <p:spTree>

</xml_diff>